<commit_message>
Reframe pitch deck around street drainage, survey speed, local resolution
Emphasizes three themes throughout: identifying street drainage gaps
(undersized basins, missing inlets, ponding pockets), faster survey
turnaround than FEMA's 5-10 year refresh cycle, and curb-level
risk resolution vs zone-level averages.

Co-Authored-By: Claude Opus 4.7 (1M context) <noreply@anthropic.com>
</commit_message>
<xml_diff>
--- a/presentation/CurbRisk_Pitch.pptx
+++ b/presentation/CurbRisk_Pitch.pptx
@@ -3293,7 +3293,7 @@
                 </a:solidFill>
                 <a:latin typeface="Calibri"/>
               </a:rPr>
-              <a:t>Street-level drainage risk scoring from LiDAR + pavement + 311.</a:t>
+              <a:t>Curb-level drainage risk, surveyed in days — not a FEMA cycle.</a:t>
             </a:r>
           </a:p>
         </p:txBody>
@@ -3503,7 +3503,7 @@
                 </a:solidFill>
                 <a:latin typeface="Calibri"/>
               </a:rPr>
-              <a:t>Cities and insurers price flood risk with the wrong map.</a:t>
+              <a:t>Existing flood maps miss where streets actually fail.</a:t>
             </a:r>
           </a:p>
         </p:txBody>
@@ -3661,7 +3661,7 @@
                 </a:solidFill>
                 <a:latin typeface="Calibri"/>
               </a:rPr>
-              <a:t>FEMA zones stop at the parcel.</a:t>
+              <a:t>FEMA maps are coarse and stale.</a:t>
             </a:r>
           </a:p>
         </p:txBody>
@@ -3696,7 +3696,7 @@
                 </a:solidFill>
                 <a:latin typeface="Calibri"/>
               </a:rPr>
-              <a:t>Two homes on the same block — one at a low point with a</a:t>
+              <a:t>FEMA flood maps refresh on 5–10 year cycles and</a:t>
             </a:r>
           </a:p>
           <a:p>
@@ -3708,7 +3708,7 @@
                 </a:solidFill>
                 <a:latin typeface="Calibri"/>
               </a:rPr>
-              <a:t>failing catch basin, one on a crest — pay the same premium.</a:t>
+              <a:t>average risk across entire zones. The crest house and</a:t>
             </a:r>
           </a:p>
           <a:p>
@@ -3720,7 +3720,7 @@
                 </a:solidFill>
                 <a:latin typeface="Calibri"/>
               </a:rPr>
-              <a:t/>
+              <a:t>the low-point house on the same block carry the same</a:t>
             </a:r>
           </a:p>
           <a:p>
@@ -3732,7 +3732,7 @@
                 </a:solidFill>
                 <a:latin typeface="Calibri"/>
               </a:rPr>
-              <a:t>Underwriters have no measured, coordinate-level signal</a:t>
+              <a:t>premium — and most flood losses happen outside the</a:t>
             </a:r>
           </a:p>
           <a:p>
@@ -3744,7 +3744,7 @@
                 </a:solidFill>
                 <a:latin typeface="Calibri"/>
               </a:rPr>
-              <a:t>for which addresses pond. Cat modelers (RMS, Verisk)</a:t>
+              <a:t>official zone, at street drainage failures the map</a:t>
             </a:r>
           </a:p>
           <a:p>
@@ -3756,7 +3756,7 @@
                 </a:solidFill>
                 <a:latin typeface="Calibri"/>
               </a:rPr>
-              <a:t>lack sub-zone drainage granularity.</a:t>
+              <a:t>never sees.</a:t>
             </a:r>
           </a:p>
         </p:txBody>
@@ -3914,7 +3914,7 @@
                 </a:solidFill>
                 <a:latin typeface="Calibri"/>
               </a:rPr>
-              <a:t>Budgets follow complaints, not water.</a:t>
+              <a:t>Street drainage gaps stay invisible.</a:t>
             </a:r>
           </a:p>
         </p:txBody>
@@ -3949,6 +3949,54 @@
                 </a:solidFill>
                 <a:latin typeface="Calibri"/>
               </a:rPr>
+              <a:t>Undersized basins, missing inlets, and ponding pockets</a:t>
+            </a:r>
+          </a:p>
+          <a:p>
+            <a:pPr algn="l"/>
+            <a:r>
+              <a:rPr sz="1300" b="0">
+                <a:solidFill>
+                  <a:srgbClr val="0B1F3A"/>
+                </a:solidFill>
+                <a:latin typeface="Calibri"/>
+              </a:rPr>
+              <a:t>don't appear on any flood map. Cities only learn about</a:t>
+            </a:r>
+          </a:p>
+          <a:p>
+            <a:pPr algn="l"/>
+            <a:r>
+              <a:rPr sz="1300" b="0">
+                <a:solidFill>
+                  <a:srgbClr val="0B1F3A"/>
+                </a:solidFill>
+                <a:latin typeface="Calibri"/>
+              </a:rPr>
+              <a:t>them through 311 complaints, after basements flood.</a:t>
+            </a:r>
+          </a:p>
+          <a:p>
+            <a:pPr algn="l"/>
+            <a:r>
+              <a:rPr sz="1300" b="0">
+                <a:solidFill>
+                  <a:srgbClr val="0B1F3A"/>
+                </a:solidFill>
+                <a:latin typeface="Calibri"/>
+              </a:rPr>
+              <a:t/>
+            </a:r>
+          </a:p>
+          <a:p>
+            <a:pPr algn="l"/>
+            <a:r>
+              <a:rPr sz="1300" b="0">
+                <a:solidFill>
+                  <a:srgbClr val="0B1F3A"/>
+                </a:solidFill>
+                <a:latin typeface="Calibri"/>
+              </a:rPr>
               <a:t>Streets get repaved over unresolved drainage and fail</a:t>
             </a:r>
           </a:p>
@@ -3961,7 +4009,7 @@
                 </a:solidFill>
                 <a:latin typeface="Calibri"/>
               </a:rPr>
-              <a:t>again in 18 months. The loudest neighborhood wins</a:t>
+              <a:t>again in 18 months — and 1970s-era basins now carry</a:t>
             </a:r>
           </a:p>
           <a:p>
@@ -3973,43 +4021,7 @@
                 </a:solidFill>
                 <a:latin typeface="Calibri"/>
               </a:rPr>
-              <a:t>the budget; the most hydraulically stressed one doesn't.</a:t>
-            </a:r>
-          </a:p>
-          <a:p>
-            <a:pPr algn="l"/>
-            <a:r>
-              <a:rPr sz="1300" b="0">
-                <a:solidFill>
-                  <a:srgbClr val="0B1F3A"/>
-                </a:solidFill>
-                <a:latin typeface="Calibri"/>
-              </a:rPr>
-              <a:t/>
-            </a:r>
-          </a:p>
-          <a:p>
-            <a:pPr algn="l"/>
-            <a:r>
-              <a:rPr sz="1300" b="0">
-                <a:solidFill>
-                  <a:srgbClr val="0B1F3A"/>
-                </a:solidFill>
-                <a:latin typeface="Calibri"/>
-              </a:rPr>
-              <a:t>Climate change compresses storms into shorter bursts —</a:t>
-            </a:r>
-          </a:p>
-          <a:p>
-            <a:pPr algn="l"/>
-            <a:r>
-              <a:rPr sz="1300" b="0">
-                <a:solidFill>
-                  <a:srgbClr val="0B1F3A"/>
-                </a:solidFill>
-                <a:latin typeface="Calibri"/>
-              </a:rPr>
-              <a:t>1970s-era basins now see 2020s-era loads.</a:t>
+              <a:t>2020s-era storm loads.</a:t>
             </a:r>
           </a:p>
         </p:txBody>
@@ -4298,7 +4310,7 @@
                 </a:solidFill>
                 <a:latin typeface="Calibri"/>
               </a:rPr>
-              <a:t>CurbRisk: a measured, address-level flood score.</a:t>
+              <a:t>Find every street drainage gap — in days, not years.</a:t>
             </a:r>
           </a:p>
         </p:txBody>
@@ -5045,7 +5057,7 @@
                 </a:solidFill>
                 <a:latin typeface="Calibri"/>
               </a:rPr>
-              <a:t>A 0–100 CurbRisk score per street segment, a browser-viewable 3D cross-section</a:t>
+              <a:t>Every drainage gap on every street, scored 0–100 per 30-ft segment, with a</a:t>
             </a:r>
           </a:p>
           <a:p>
@@ -5057,7 +5069,7 @@
                 </a:solidFill>
                 <a:latin typeface="Calibri"/>
               </a:rPr>
-              <a:t>of every flagged low point, and an API an underwriter queries by address in &lt; 10 s.</a:t>
+              <a:t>browser-viewable 3D cross-section of each low point. A city in weeks, not a FEMA cycle.</a:t>
             </a:r>
           </a:p>
         </p:txBody>
@@ -5381,7 +5393,7 @@
                 </a:solidFill>
                 <a:latin typeface="Calibri"/>
               </a:rPr>
-              <a:t>Four data layers nobody else has integrated.</a:t>
+              <a:t>Faster, finer, and built around the street itself.</a:t>
             </a:r>
           </a:p>
         </p:txBody>
@@ -5504,7 +5516,7 @@
                 </a:solidFill>
                 <a:latin typeface="Calibri"/>
               </a:rPr>
-              <a:t>Measured terrain, not assumed</a:t>
+              <a:t>Days, not decades</a:t>
             </a:r>
           </a:p>
         </p:txBody>
@@ -5539,7 +5551,7 @@
                 </a:solidFill>
                 <a:latin typeface="Calibri"/>
               </a:rPr>
-              <a:t>Mobile LiDAR captures the 2-inch crown differential that 1-meter DEMs miss. We see where water actually goes.</a:t>
+              <a:t>FEMA flood maps refresh on 5–10 year cycles. Cyvl mobile LiDAR scans a city in a single drive; CurbRisk re-scores the network in days. Drainage projects don't have to wait on a federal map update.</a:t>
             </a:r>
           </a:p>
         </p:txBody>
@@ -5662,7 +5674,7 @@
                 </a:solidFill>
                 <a:latin typeface="Calibri"/>
               </a:rPr>
-              <a:t>Pavement + drainage in one model</a:t>
+              <a:t>Curb-level, not zone-level</a:t>
             </a:r>
           </a:p>
         </p:txBody>
@@ -5697,7 +5709,7 @@
                 </a:solidFill>
                 <a:latin typeface="Calibri"/>
               </a:rPr>
-              <a:t>Cyvl PCI scores tell us where the road is already weak; terrain tells us where water lands on it. The intersection is where potholes reappear.</a:t>
+              <a:t>FEMA averages risk across whole zones. CurbRisk scores every 30-ft pavement segment and every detected low point — measured terrain, local impervious cover, real complaint history.</a:t>
             </a:r>
           </a:p>
         </p:txBody>
@@ -5820,7 +5832,7 @@
                 </a:solidFill>
                 <a:latin typeface="Calibri"/>
               </a:rPr>
-              <a:t>311 as ground truth</a:t>
+              <a:t>Street drainage gaps, not just floodplains</a:t>
             </a:r>
           </a:p>
         </p:txBody>
@@ -5855,7 +5867,7 @@
                 </a:solidFill>
                 <a:latin typeface="Calibri"/>
               </a:rPr>
-              <a:t>144 Somerville flooding reports validate every modeled low point. If complaints cluster on our high-risk segments, the model is right.</a:t>
+              <a:t>Identifies undersized basins, missing inlets, ponding pockets, and flow-concentration points — the failure mode that floods basements outside the official flood zone, that no flood map shows.</a:t>
             </a:r>
           </a:p>
         </p:txBody>
@@ -5978,7 +5990,7 @@
                 </a:solidFill>
                 <a:latin typeface="Calibri"/>
               </a:rPr>
-              <a:t>Autodesk-ready, browser-viewable</a:t>
+              <a:t>Validated + Autodesk-delivered</a:t>
             </a:r>
           </a:p>
         </p:txBody>
@@ -6013,7 +6025,7 @@
                 </a:solidFill>
                 <a:latin typeface="Calibri"/>
               </a:rPr>
-              <a:t>Every flagged low point exports as an APS cross-section an underwriter opens in a browser — and a civil engineer opens in Civil 3D.</a:t>
+              <a:t>144 Somerville flooding 311s ground-truth the model. Every flagged location exports as a browser-viewable APS cross-section — engineers in Civil 3D, underwriters in a browser.</a:t>
             </a:r>
           </a:p>
         </p:txBody>
@@ -6048,7 +6060,7 @@
                 </a:solidFill>
                 <a:latin typeface="Calibri"/>
               </a:rPr>
-              <a:t>The moat: nobody else holds measured LiDAR + pavement condition + drainage hydrology + Autodesk delivery in one stack.</a:t>
+              <a:t>Where FEMA gives you a polygon every 5 years, CurbRisk gives you every drainage gap on every street, this month.</a:t>
             </a:r>
           </a:p>
         </p:txBody>
@@ -8874,7 +8886,7 @@
                 </a:solidFill>
                 <a:latin typeface="Calibri"/>
               </a:rPr>
-              <a:t>Stop pricing flood risk with a map that ends at the parcel.</a:t>
+              <a:t>Stop waiting on a federal map cycle to find a failing catch basin.</a:t>
             </a:r>
           </a:p>
         </p:txBody>
@@ -8909,7 +8921,7 @@
                 </a:solidFill>
                 <a:latin typeface="Calibri"/>
               </a:rPr>
-              <a:t>Start pricing it with the one that ends at the curb.</a:t>
+              <a:t>Score every street drainage gap, every block, every month.</a:t>
             </a:r>
           </a:p>
         </p:txBody>

</xml_diff>